<commit_message>
feat: add new presentation slides and markdown files for AI-Assisted Software Development course
</commit_message>
<xml_diff>
--- a/Slides/individual-slides/chat-mode.pptx
+++ b/Slides/individual-slides/chat-mode.pptx
@@ -1,11 +1,11 @@
 
 <file path=ppt/presentation.xml><?xml version="1.0" encoding="utf-8"?>
-<p:presentation xmlns:a="http://schemas.openxmlformats.org/drawingml/2006/main" xmlns:p="http://schemas.openxmlformats.org/presentationml/2006/main" xmlns:r="http://schemas.openxmlformats.org/officeDocument/2006/relationships" autoCompressPictures="0" saveSubsetFonts="1">
+<p:presentation xmlns:a="http://schemas.openxmlformats.org/drawingml/2006/main" xmlns:r="http://schemas.openxmlformats.org/officeDocument/2006/relationships" xmlns:p="http://schemas.openxmlformats.org/presentationml/2006/main" saveSubsetFonts="1" autoCompressPictures="0">
   <p:sldMasterIdLst>
     <p:sldMasterId id="2147483648" r:id="rId1"/>
   </p:sldMasterIdLst>
   <p:notesMasterIdLst>
-    <p:notesMasterId r:id="rId13"/>
+    <p:notesMasterId r:id="rId14"/>
   </p:notesMasterIdLst>
   <p:sldIdLst>
     <p:sldId id="256" r:id="rId2"/>
@@ -19,6 +19,7 @@
     <p:sldId id="264" r:id="rId10"/>
     <p:sldId id="265" r:id="rId11"/>
     <p:sldId id="266" r:id="rId12"/>
+    <p:sldId id="287" r:id="rId13"/>
   </p:sldIdLst>
   <p:sldSz cx="9144000" cy="5143500" type="screen16x9"/>
   <p:notesSz cx="6858000" cy="9144000"/>
@@ -26,8 +27,8 @@
     <a:defPPr>
       <a:defRPr lang="en-US"/>
     </a:defPPr>
-    <a:lvl1pPr algn="l" defTabSz="457200" eaLnBrk="1" hangingPunct="1" latinLnBrk="0" marL="0" rtl="0">
-      <a:defRPr kern="1200" sz="1800">
+    <a:lvl1pPr marL="0" algn="l" defTabSz="457200" rtl="0" eaLnBrk="1" latinLnBrk="0" hangingPunct="1">
+      <a:defRPr sz="1800" kern="1200">
         <a:solidFill>
           <a:schemeClr val="tx1"/>
         </a:solidFill>
@@ -36,8 +37,8 @@
         <a:cs typeface="+mn-cs"/>
       </a:defRPr>
     </a:lvl1pPr>
-    <a:lvl2pPr algn="l" defTabSz="457200" eaLnBrk="1" hangingPunct="1" latinLnBrk="0" marL="457200" rtl="0">
-      <a:defRPr kern="1200" sz="1800">
+    <a:lvl2pPr marL="457200" algn="l" defTabSz="457200" rtl="0" eaLnBrk="1" latinLnBrk="0" hangingPunct="1">
+      <a:defRPr sz="1800" kern="1200">
         <a:solidFill>
           <a:schemeClr val="tx1"/>
         </a:solidFill>
@@ -46,8 +47,8 @@
         <a:cs typeface="+mn-cs"/>
       </a:defRPr>
     </a:lvl2pPr>
-    <a:lvl3pPr algn="l" defTabSz="457200" eaLnBrk="1" hangingPunct="1" latinLnBrk="0" marL="914400" rtl="0">
-      <a:defRPr kern="1200" sz="1800">
+    <a:lvl3pPr marL="914400" algn="l" defTabSz="457200" rtl="0" eaLnBrk="1" latinLnBrk="0" hangingPunct="1">
+      <a:defRPr sz="1800" kern="1200">
         <a:solidFill>
           <a:schemeClr val="tx1"/>
         </a:solidFill>
@@ -56,8 +57,8 @@
         <a:cs typeface="+mn-cs"/>
       </a:defRPr>
     </a:lvl3pPr>
-    <a:lvl4pPr algn="l" defTabSz="457200" eaLnBrk="1" hangingPunct="1" latinLnBrk="0" marL="1371600" rtl="0">
-      <a:defRPr kern="1200" sz="1800">
+    <a:lvl4pPr marL="1371600" algn="l" defTabSz="457200" rtl="0" eaLnBrk="1" latinLnBrk="0" hangingPunct="1">
+      <a:defRPr sz="1800" kern="1200">
         <a:solidFill>
           <a:schemeClr val="tx1"/>
         </a:solidFill>
@@ -66,8 +67,8 @@
         <a:cs typeface="+mn-cs"/>
       </a:defRPr>
     </a:lvl4pPr>
-    <a:lvl5pPr algn="l" defTabSz="457200" eaLnBrk="1" hangingPunct="1" latinLnBrk="0" marL="1828800" rtl="0">
-      <a:defRPr kern="1200" sz="1800">
+    <a:lvl5pPr marL="1828800" algn="l" defTabSz="457200" rtl="0" eaLnBrk="1" latinLnBrk="0" hangingPunct="1">
+      <a:defRPr sz="1800" kern="1200">
         <a:solidFill>
           <a:schemeClr val="tx1"/>
         </a:solidFill>
@@ -76,8 +77,8 @@
         <a:cs typeface="+mn-cs"/>
       </a:defRPr>
     </a:lvl5pPr>
-    <a:lvl6pPr algn="l" defTabSz="457200" eaLnBrk="1" hangingPunct="1" latinLnBrk="0" marL="2286000" rtl="0">
-      <a:defRPr kern="1200" sz="1800">
+    <a:lvl6pPr marL="2286000" algn="l" defTabSz="457200" rtl="0" eaLnBrk="1" latinLnBrk="0" hangingPunct="1">
+      <a:defRPr sz="1800" kern="1200">
         <a:solidFill>
           <a:schemeClr val="tx1"/>
         </a:solidFill>
@@ -86,8 +87,8 @@
         <a:cs typeface="+mn-cs"/>
       </a:defRPr>
     </a:lvl6pPr>
-    <a:lvl7pPr algn="l" defTabSz="457200" eaLnBrk="1" hangingPunct="1" latinLnBrk="0" marL="2743200" rtl="0">
-      <a:defRPr kern="1200" sz="1800">
+    <a:lvl7pPr marL="2743200" algn="l" defTabSz="457200" rtl="0" eaLnBrk="1" latinLnBrk="0" hangingPunct="1">
+      <a:defRPr sz="1800" kern="1200">
         <a:solidFill>
           <a:schemeClr val="tx1"/>
         </a:solidFill>
@@ -96,8 +97,8 @@
         <a:cs typeface="+mn-cs"/>
       </a:defRPr>
     </a:lvl7pPr>
-    <a:lvl8pPr algn="l" defTabSz="457200" eaLnBrk="1" hangingPunct="1" latinLnBrk="0" marL="3200400" rtl="0">
-      <a:defRPr kern="1200" sz="1800">
+    <a:lvl8pPr marL="3200400" algn="l" defTabSz="457200" rtl="0" eaLnBrk="1" latinLnBrk="0" hangingPunct="1">
+      <a:defRPr sz="1800" kern="1200">
         <a:solidFill>
           <a:schemeClr val="tx1"/>
         </a:solidFill>
@@ -106,8 +107,8 @@
         <a:cs typeface="+mn-cs"/>
       </a:defRPr>
     </a:lvl8pPr>
-    <a:lvl9pPr algn="l" defTabSz="457200" eaLnBrk="1" hangingPunct="1" latinLnBrk="0" marL="3657600" rtl="0">
-      <a:defRPr kern="1200" sz="1800">
+    <a:lvl9pPr marL="3657600" algn="l" defTabSz="457200" rtl="0" eaLnBrk="1" latinLnBrk="0" hangingPunct="1">
+      <a:defRPr sz="1800" kern="1200">
         <a:solidFill>
           <a:schemeClr val="tx1"/>
         </a:solidFill>
@@ -218,7 +219,7 @@
           <a:p>
             <a:fld id="{0F9C1CCF-B725-44A7-AA57-5E433BD85C9F}" type="datetimeFigureOut">
               <a:rPr lang="en-US" smtClean="0"/>
-              <a:t>1/2/22</a:t>
+              <a:t>3/6/2026</a:t>
             </a:fld>
             <a:endParaRPr lang="en-US"/>
           </a:p>
@@ -529,11 +530,10 @@
           <a:bodyPr/>
           <a:lstStyle/>
           <a:p>
-            <a:pPr lvl="0" indent="0" marL="0">
+            <a:pPr marL="0" lvl="0" indent="0">
               <a:buNone/>
             </a:pPr>
             <a:r>
-              <a:rPr/>
               <a:t>This deck summarizes all folder and filename constraints for Copilot’s instruction system and incorporates the ongoing rename of “chat modes” to “agents.”</a:t>
             </a:r>
           </a:p>
@@ -564,6 +564,9 @@
       </p:sp>
     </p:spTree>
   </p:cSld>
+  <p:clrMapOvr>
+    <a:masterClrMapping/>
+  </p:clrMapOvr>
 </p:notes>
 </file>
 
@@ -611,11 +614,10 @@
           <a:bodyPr/>
           <a:lstStyle/>
           <a:p>
-            <a:pPr lvl="0" indent="0" marL="0">
+            <a:pPr marL="0" lvl="0" indent="0">
               <a:buNone/>
             </a:pPr>
             <a:r>
-              <a:rPr/>
               <a:t>The rename is conceptual and UI‑level for now. The underlying filesystem rules remain unchanged.</a:t>
             </a:r>
           </a:p>
@@ -646,6 +648,9 @@
       </p:sp>
     </p:spTree>
   </p:cSld>
+  <p:clrMapOvr>
+    <a:masterClrMapping/>
+  </p:clrMapOvr>
 </p:notes>
 </file>
 
@@ -693,11 +698,10 @@
           <a:bodyPr/>
           <a:lstStyle/>
           <a:p>
-            <a:pPr lvl="0" indent="0" marL="0">
+            <a:pPr marL="0" lvl="0" indent="0">
               <a:buNone/>
             </a:pPr>
             <a:r>
-              <a:rPr/>
               <a:t>Even though “chat modes” are being renamed to “agents,” the folder name remains </a:t>
             </a:r>
             <a:r>
@@ -707,7 +711,6 @@
               <a:t>.github/copilot/chat_modes/</a:t>
             </a:r>
             <a:r>
-              <a:rPr/>
               <a:t> for now.</a:t>
             </a:r>
           </a:p>
@@ -738,6 +741,9 @@
       </p:sp>
     </p:spTree>
   </p:cSld>
+  <p:clrMapOvr>
+    <a:masterClrMapping/>
+  </p:clrMapOvr>
 </p:notes>
 </file>
 
@@ -785,11 +791,10 @@
           <a:bodyPr/>
           <a:lstStyle/>
           <a:p>
-            <a:pPr lvl="0" indent="0" marL="0">
+            <a:pPr marL="0" lvl="0" indent="0">
               <a:buNone/>
             </a:pPr>
             <a:r>
-              <a:rPr/>
               <a:t>Teams can safely start using the term “agent” in training and inside the file’s </a:t>
             </a:r>
             <a:r>
@@ -799,7 +804,6 @@
               <a:t>name:</a:t>
             </a:r>
             <a:r>
-              <a:rPr/>
               <a:t> field, but must keep the existing folder structure.</a:t>
             </a:r>
           </a:p>
@@ -830,6 +834,9 @@
       </p:sp>
     </p:spTree>
   </p:cSld>
+  <p:clrMapOvr>
+    <a:masterClrMapping/>
+  </p:clrMapOvr>
 </p:notes>
 </file>
 
@@ -1012,7 +1019,7 @@
           <a:p>
             <a:fld id="{241EB5C9-1307-BA42-ABA2-0BC069CD8E7F}" type="datetimeFigureOut">
               <a:rPr lang="en-US" smtClean="0"/>
-              <a:t>1/2/22</a:t>
+              <a:t>3/6/2026</a:t>
             </a:fld>
             <a:endParaRPr lang="en-US"/>
           </a:p>
@@ -1180,7 +1187,7 @@
           <a:p>
             <a:fld id="{241EB5C9-1307-BA42-ABA2-0BC069CD8E7F}" type="datetimeFigureOut">
               <a:rPr lang="en-US" smtClean="0"/>
-              <a:t>1/2/22</a:t>
+              <a:t>3/6/2026</a:t>
             </a:fld>
             <a:endParaRPr lang="en-US"/>
           </a:p>
@@ -1358,7 +1365,7 @@
           <a:p>
             <a:fld id="{241EB5C9-1307-BA42-ABA2-0BC069CD8E7F}" type="datetimeFigureOut">
               <a:rPr lang="en-US" smtClean="0"/>
-              <a:t>1/2/22</a:t>
+              <a:t>3/6/2026</a:t>
             </a:fld>
             <a:endParaRPr lang="en-US"/>
           </a:p>
@@ -1526,7 +1533,7 @@
           <a:p>
             <a:fld id="{241EB5C9-1307-BA42-ABA2-0BC069CD8E7F}" type="datetimeFigureOut">
               <a:rPr lang="en-US" smtClean="0"/>
-              <a:t>1/2/22</a:t>
+              <a:t>3/6/2026</a:t>
             </a:fld>
             <a:endParaRPr lang="en-US"/>
           </a:p>
@@ -1771,7 +1778,7 @@
           <a:p>
             <a:fld id="{241EB5C9-1307-BA42-ABA2-0BC069CD8E7F}" type="datetimeFigureOut">
               <a:rPr lang="en-US" smtClean="0"/>
-              <a:t>1/2/22</a:t>
+              <a:t>3/6/2026</a:t>
             </a:fld>
             <a:endParaRPr lang="en-US"/>
           </a:p>
@@ -2056,7 +2063,7 @@
           <a:p>
             <a:fld id="{241EB5C9-1307-BA42-ABA2-0BC069CD8E7F}" type="datetimeFigureOut">
               <a:rPr lang="en-US" smtClean="0"/>
-              <a:t>1/2/22</a:t>
+              <a:t>3/6/2026</a:t>
             </a:fld>
             <a:endParaRPr lang="en-US"/>
           </a:p>
@@ -2475,7 +2482,7 @@
           <a:p>
             <a:fld id="{241EB5C9-1307-BA42-ABA2-0BC069CD8E7F}" type="datetimeFigureOut">
               <a:rPr lang="en-US" smtClean="0"/>
-              <a:t>1/2/22</a:t>
+              <a:t>3/6/2026</a:t>
             </a:fld>
             <a:endParaRPr lang="en-US"/>
           </a:p>
@@ -2592,7 +2599,7 @@
           <a:p>
             <a:fld id="{241EB5C9-1307-BA42-ABA2-0BC069CD8E7F}" type="datetimeFigureOut">
               <a:rPr lang="en-US" smtClean="0"/>
-              <a:t>1/2/22</a:t>
+              <a:t>3/6/2026</a:t>
             </a:fld>
             <a:endParaRPr lang="en-US"/>
           </a:p>
@@ -2687,7 +2694,7 @@
           <a:p>
             <a:fld id="{241EB5C9-1307-BA42-ABA2-0BC069CD8E7F}" type="datetimeFigureOut">
               <a:rPr lang="en-US" smtClean="0"/>
-              <a:t>1/2/22</a:t>
+              <a:t>3/6/2026</a:t>
             </a:fld>
             <a:endParaRPr lang="en-US"/>
           </a:p>
@@ -2962,7 +2969,7 @@
           <a:p>
             <a:fld id="{241EB5C9-1307-BA42-ABA2-0BC069CD8E7F}" type="datetimeFigureOut">
               <a:rPr lang="en-US" smtClean="0"/>
-              <a:t>1/2/22</a:t>
+              <a:t>3/6/2026</a:t>
             </a:fld>
             <a:endParaRPr lang="en-US"/>
           </a:p>
@@ -3214,7 +3221,7 @@
           <a:p>
             <a:fld id="{241EB5C9-1307-BA42-ABA2-0BC069CD8E7F}" type="datetimeFigureOut">
               <a:rPr lang="en-US" smtClean="0"/>
-              <a:t>1/2/22</a:t>
+              <a:t>3/6/2026</a:t>
             </a:fld>
             <a:endParaRPr lang="en-US"/>
           </a:p>
@@ -3276,7 +3283,7 @@
 </file>
 
 <file path=ppt/slideMasters/slideMaster1.xml><?xml version="1.0" encoding="utf-8"?>
-<p:sldMaster xmlns:a="http://schemas.openxmlformats.org/drawingml/2006/main" xmlns:p="http://schemas.openxmlformats.org/presentationml/2006/main" xmlns:r="http://schemas.openxmlformats.org/officeDocument/2006/relationships">
+<p:sldMaster xmlns:a="http://schemas.openxmlformats.org/drawingml/2006/main" xmlns:r="http://schemas.openxmlformats.org/officeDocument/2006/relationships" xmlns:p="http://schemas.openxmlformats.org/presentationml/2006/main">
   <p:cSld>
     <p:bg>
       <p:bgRef idx="1001">
@@ -3317,7 +3324,7 @@
           </a:prstGeom>
         </p:spPr>
         <p:txBody>
-          <a:bodyPr anchor="ctr" bIns="45720" lIns="91440" rIns="91440" rtlCol="0" tIns="45720" vert="horz">
+          <a:bodyPr vert="horz" lIns="91440" tIns="45720" rIns="91440" bIns="45720" rtlCol="0" anchor="ctr">
             <a:normAutofit/>
           </a:bodyPr>
           <a:lstStyle/>
@@ -3336,7 +3343,7 @@
             <a:spLocks noGrp="1"/>
           </p:cNvSpPr>
           <p:nvPr>
-            <p:ph idx="1" type="body"/>
+            <p:ph type="body" idx="1"/>
           </p:nvPr>
         </p:nvSpPr>
         <p:spPr>
@@ -3349,7 +3356,7 @@
           </a:prstGeom>
         </p:spPr>
         <p:txBody>
-          <a:bodyPr bIns="45720" lIns="91440" rIns="91440" rtlCol="0" tIns="45720" vert="horz">
+          <a:bodyPr vert="horz" lIns="91440" tIns="45720" rIns="91440" bIns="45720" rtlCol="0">
             <a:normAutofit/>
           </a:bodyPr>
           <a:lstStyle/>
@@ -3397,7 +3404,7 @@
             <a:spLocks noGrp="1"/>
           </p:cNvSpPr>
           <p:nvPr>
-            <p:ph idx="2" sz="half" type="dt"/>
+            <p:ph type="dt" sz="half" idx="2"/>
           </p:nvPr>
         </p:nvSpPr>
         <p:spPr>
@@ -3410,7 +3417,7 @@
           </a:prstGeom>
         </p:spPr>
         <p:txBody>
-          <a:bodyPr anchor="ctr" bIns="45720" lIns="91440" rIns="91440" rtlCol="0" tIns="45720" vert="horz"/>
+          <a:bodyPr vert="horz" lIns="91440" tIns="45720" rIns="91440" bIns="45720" rtlCol="0" anchor="ctr"/>
           <a:lstStyle>
             <a:lvl1pPr algn="l">
               <a:defRPr sz="900">
@@ -3425,7 +3432,7 @@
           <a:p>
             <a:fld id="{241EB5C9-1307-BA42-ABA2-0BC069CD8E7F}" type="datetimeFigureOut">
               <a:rPr lang="en-US" smtClean="0"/>
-              <a:t>1/2/22</a:t>
+              <a:t>3/6/2026</a:t>
             </a:fld>
             <a:endParaRPr lang="en-US"/>
           </a:p>
@@ -3438,7 +3445,7 @@
             <a:spLocks noGrp="1"/>
           </p:cNvSpPr>
           <p:nvPr>
-            <p:ph idx="3" sz="quarter" type="ftr"/>
+            <p:ph type="ftr" sz="quarter" idx="3"/>
           </p:nvPr>
         </p:nvSpPr>
         <p:spPr>
@@ -3451,7 +3458,7 @@
           </a:prstGeom>
         </p:spPr>
         <p:txBody>
-          <a:bodyPr anchor="ctr" bIns="45720" lIns="91440" rIns="91440" rtlCol="0" tIns="45720" vert="horz"/>
+          <a:bodyPr vert="horz" lIns="91440" tIns="45720" rIns="91440" bIns="45720" rtlCol="0" anchor="ctr"/>
           <a:lstStyle>
             <a:lvl1pPr algn="ctr">
               <a:defRPr sz="900">
@@ -3475,7 +3482,7 @@
             <a:spLocks noGrp="1"/>
           </p:cNvSpPr>
           <p:nvPr>
-            <p:ph idx="4" sz="quarter" type="sldNum"/>
+            <p:ph type="sldNum" sz="quarter" idx="4"/>
           </p:nvPr>
         </p:nvSpPr>
         <p:spPr>
@@ -3488,7 +3495,7 @@
           </a:prstGeom>
         </p:spPr>
         <p:txBody>
-          <a:bodyPr anchor="ctr" bIns="45720" lIns="91440" rIns="91440" rtlCol="0" tIns="45720" vert="horz"/>
+          <a:bodyPr vert="horz" lIns="91440" tIns="45720" rIns="91440" bIns="45720" rtlCol="0" anchor="ctr"/>
           <a:lstStyle>
             <a:lvl1pPr algn="r">
               <a:defRPr sz="900">
@@ -3516,7 +3523,7 @@
       </p:ext>
     </p:extLst>
   </p:cSld>
-  <p:clrMap accent1="accent1" accent2="accent2" accent3="accent3" accent4="accent4" accent5="accent5" accent6="accent6" bg1="lt1" bg2="lt2" folHlink="folHlink" hlink="hlink" tx1="dk1" tx2="dk2"/>
+  <p:clrMap bg1="lt1" tx1="dk1" bg2="lt2" tx2="dk2" accent1="accent1" accent2="accent2" accent3="accent3" accent4="accent4" accent5="accent5" accent6="accent6" hlink="hlink" folHlink="folHlink"/>
   <p:sldLayoutIdLst>
     <p:sldLayoutId id="2147483649" r:id="rId1"/>
     <p:sldLayoutId id="2147483650" r:id="rId2"/>
@@ -3532,12 +3539,12 @@
   </p:sldLayoutIdLst>
   <p:txStyles>
     <p:titleStyle>
-      <a:lvl1pPr algn="ctr" defTabSz="342900" eaLnBrk="1" hangingPunct="1" latinLnBrk="0" rtl="0">
+      <a:lvl1pPr algn="ctr" defTabSz="342900" rtl="0" eaLnBrk="1" latinLnBrk="0" hangingPunct="1">
         <a:spcBef>
           <a:spcPct val="0"/>
         </a:spcBef>
         <a:buNone/>
-        <a:defRPr kern="1200" sz="3300">
+        <a:defRPr sz="3300" kern="1200">
           <a:solidFill>
             <a:schemeClr val="tx1"/>
           </a:solidFill>
@@ -3548,13 +3555,13 @@
       </a:lvl1pPr>
     </p:titleStyle>
     <p:bodyStyle>
-      <a:lvl1pPr algn="l" defTabSz="342900" eaLnBrk="1" hangingPunct="1" indent="-342900" latinLnBrk="0" marL="342900" rtl="0">
+      <a:lvl1pPr marL="342900" indent="-342900" algn="l" defTabSz="342900" rtl="0" eaLnBrk="1" latinLnBrk="0" hangingPunct="1">
         <a:spcBef>
           <a:spcPct val="20000"/>
         </a:spcBef>
         <a:buFont typeface="Arial"/>
         <a:buChar char="•"/>
-        <a:defRPr kern="1200" sz="2400">
+        <a:defRPr sz="2400" kern="1200">
           <a:solidFill>
             <a:schemeClr val="tx1"/>
           </a:solidFill>
@@ -3563,13 +3570,13 @@
           <a:cs typeface="+mn-cs"/>
         </a:defRPr>
       </a:lvl1pPr>
-      <a:lvl2pPr algn="l" defTabSz="342900" eaLnBrk="1" hangingPunct="1" indent="-342900" latinLnBrk="0" marL="685800" rtl="0">
+      <a:lvl2pPr marL="685800" indent="-342900" algn="l" defTabSz="342900" rtl="0" eaLnBrk="1" latinLnBrk="0" hangingPunct="1">
         <a:spcBef>
           <a:spcPct val="20000"/>
         </a:spcBef>
         <a:buFont typeface="Arial"/>
         <a:buChar char="–"/>
-        <a:defRPr kern="1200" sz="2100">
+        <a:defRPr sz="2100" kern="1200">
           <a:solidFill>
             <a:schemeClr val="tx1"/>
           </a:solidFill>
@@ -3578,13 +3585,13 @@
           <a:cs typeface="+mn-cs"/>
         </a:defRPr>
       </a:lvl2pPr>
-      <a:lvl3pPr algn="l" defTabSz="342900" eaLnBrk="1" hangingPunct="1" indent="-342900" latinLnBrk="0" marL="1028700" rtl="0">
+      <a:lvl3pPr marL="1028700" indent="-342900" algn="l" defTabSz="342900" rtl="0" eaLnBrk="1" latinLnBrk="0" hangingPunct="1">
         <a:spcBef>
           <a:spcPct val="20000"/>
         </a:spcBef>
         <a:buFont typeface="Arial"/>
         <a:buChar char="•"/>
-        <a:defRPr kern="1200" sz="1800">
+        <a:defRPr sz="1800" kern="1200">
           <a:solidFill>
             <a:schemeClr val="tx1"/>
           </a:solidFill>
@@ -3593,13 +3600,13 @@
           <a:cs typeface="+mn-cs"/>
         </a:defRPr>
       </a:lvl3pPr>
-      <a:lvl4pPr algn="l" defTabSz="342900" eaLnBrk="1" hangingPunct="1" indent="-342900" latinLnBrk="0" marL="1371600" rtl="0">
+      <a:lvl4pPr marL="1371600" indent="-342900" algn="l" defTabSz="342900" rtl="0" eaLnBrk="1" latinLnBrk="0" hangingPunct="1">
         <a:spcBef>
           <a:spcPct val="20000"/>
         </a:spcBef>
         <a:buFont typeface="Arial"/>
         <a:buChar char="–"/>
-        <a:defRPr kern="1200" sz="1500">
+        <a:defRPr sz="1500" kern="1200">
           <a:solidFill>
             <a:schemeClr val="tx1"/>
           </a:solidFill>
@@ -3608,13 +3615,13 @@
           <a:cs typeface="+mn-cs"/>
         </a:defRPr>
       </a:lvl4pPr>
-      <a:lvl5pPr algn="l" defTabSz="342900" eaLnBrk="1" hangingPunct="1" indent="-342900" latinLnBrk="0" marL="1714500" rtl="0">
+      <a:lvl5pPr marL="1714500" indent="-342900" algn="l" defTabSz="342900" rtl="0" eaLnBrk="1" latinLnBrk="0" hangingPunct="1">
         <a:spcBef>
           <a:spcPct val="20000"/>
         </a:spcBef>
         <a:buFont typeface="Arial"/>
         <a:buChar char="»"/>
-        <a:defRPr kern="1200" sz="1500">
+        <a:defRPr sz="1500" kern="1200">
           <a:solidFill>
             <a:schemeClr val="tx1"/>
           </a:solidFill>
@@ -3623,13 +3630,13 @@
           <a:cs typeface="+mn-cs"/>
         </a:defRPr>
       </a:lvl5pPr>
-      <a:lvl6pPr algn="l" defTabSz="342900" eaLnBrk="1" hangingPunct="1" indent="-342900" latinLnBrk="0" marL="2057400" rtl="0">
+      <a:lvl6pPr marL="2057400" indent="-342900" algn="l" defTabSz="342900" rtl="0" eaLnBrk="1" latinLnBrk="0" hangingPunct="1">
         <a:spcBef>
           <a:spcPct val="20000"/>
         </a:spcBef>
         <a:buFont typeface="Arial"/>
         <a:buChar char="•"/>
-        <a:defRPr kern="1200" sz="1500">
+        <a:defRPr sz="1500" kern="1200">
           <a:solidFill>
             <a:schemeClr val="tx1"/>
           </a:solidFill>
@@ -3638,13 +3645,13 @@
           <a:cs typeface="+mn-cs"/>
         </a:defRPr>
       </a:lvl6pPr>
-      <a:lvl7pPr algn="l" defTabSz="342900" eaLnBrk="1" hangingPunct="1" indent="-342900" latinLnBrk="0" marL="2400300" rtl="0">
+      <a:lvl7pPr marL="2400300" indent="-342900" algn="l" defTabSz="342900" rtl="0" eaLnBrk="1" latinLnBrk="0" hangingPunct="1">
         <a:spcBef>
           <a:spcPct val="20000"/>
         </a:spcBef>
         <a:buFont typeface="Arial"/>
         <a:buChar char="•"/>
-        <a:defRPr kern="1200" sz="1500">
+        <a:defRPr sz="1500" kern="1200">
           <a:solidFill>
             <a:schemeClr val="tx1"/>
           </a:solidFill>
@@ -3653,13 +3660,13 @@
           <a:cs typeface="+mn-cs"/>
         </a:defRPr>
       </a:lvl7pPr>
-      <a:lvl8pPr algn="l" defTabSz="342900" eaLnBrk="1" hangingPunct="1" indent="-342900" latinLnBrk="0" marL="2743200" rtl="0">
+      <a:lvl8pPr marL="2743200" indent="-342900" algn="l" defTabSz="342900" rtl="0" eaLnBrk="1" latinLnBrk="0" hangingPunct="1">
         <a:spcBef>
           <a:spcPct val="20000"/>
         </a:spcBef>
         <a:buFont typeface="Arial"/>
         <a:buChar char="•"/>
-        <a:defRPr kern="1200" sz="1500">
+        <a:defRPr sz="1500" kern="1200">
           <a:solidFill>
             <a:schemeClr val="tx1"/>
           </a:solidFill>
@@ -3668,13 +3675,13 @@
           <a:cs typeface="+mn-cs"/>
         </a:defRPr>
       </a:lvl8pPr>
-      <a:lvl9pPr algn="l" defTabSz="342900" eaLnBrk="1" hangingPunct="1" indent="-342900" latinLnBrk="0" marL="3086100" rtl="0">
+      <a:lvl9pPr marL="3086100" indent="-342900" algn="l" defTabSz="342900" rtl="0" eaLnBrk="1" latinLnBrk="0" hangingPunct="1">
         <a:spcBef>
           <a:spcPct val="20000"/>
         </a:spcBef>
         <a:buFont typeface="Arial"/>
         <a:buChar char="•"/>
-        <a:defRPr kern="1200" sz="1500">
+        <a:defRPr sz="1500" kern="1200">
           <a:solidFill>
             <a:schemeClr val="tx1"/>
           </a:solidFill>
@@ -3688,8 +3695,8 @@
       <a:defPPr>
         <a:defRPr lang="en-US"/>
       </a:defPPr>
-      <a:lvl1pPr algn="l" defTabSz="342900" eaLnBrk="1" hangingPunct="1" latinLnBrk="0" marL="0" rtl="0">
-        <a:defRPr kern="1200" sz="1350">
+      <a:lvl1pPr marL="0" algn="l" defTabSz="342900" rtl="0" eaLnBrk="1" latinLnBrk="0" hangingPunct="1">
+        <a:defRPr sz="1350" kern="1200">
           <a:solidFill>
             <a:schemeClr val="tx1"/>
           </a:solidFill>
@@ -3698,8 +3705,8 @@
           <a:cs typeface="+mn-cs"/>
         </a:defRPr>
       </a:lvl1pPr>
-      <a:lvl2pPr algn="l" defTabSz="342900" eaLnBrk="1" hangingPunct="1" latinLnBrk="0" marL="342900" rtl="0">
-        <a:defRPr kern="1200" sz="1350">
+      <a:lvl2pPr marL="342900" algn="l" defTabSz="342900" rtl="0" eaLnBrk="1" latinLnBrk="0" hangingPunct="1">
+        <a:defRPr sz="1350" kern="1200">
           <a:solidFill>
             <a:schemeClr val="tx1"/>
           </a:solidFill>
@@ -3708,8 +3715,8 @@
           <a:cs typeface="+mn-cs"/>
         </a:defRPr>
       </a:lvl2pPr>
-      <a:lvl3pPr algn="l" defTabSz="342900" eaLnBrk="1" hangingPunct="1" latinLnBrk="0" marL="685800" rtl="0">
-        <a:defRPr kern="1200" sz="1350">
+      <a:lvl3pPr marL="685800" algn="l" defTabSz="342900" rtl="0" eaLnBrk="1" latinLnBrk="0" hangingPunct="1">
+        <a:defRPr sz="1350" kern="1200">
           <a:solidFill>
             <a:schemeClr val="tx1"/>
           </a:solidFill>
@@ -3718,8 +3725,8 @@
           <a:cs typeface="+mn-cs"/>
         </a:defRPr>
       </a:lvl3pPr>
-      <a:lvl4pPr algn="l" defTabSz="342900" eaLnBrk="1" hangingPunct="1" latinLnBrk="0" marL="1028700" rtl="0">
-        <a:defRPr kern="1200" sz="1350">
+      <a:lvl4pPr marL="1028700" algn="l" defTabSz="342900" rtl="0" eaLnBrk="1" latinLnBrk="0" hangingPunct="1">
+        <a:defRPr sz="1350" kern="1200">
           <a:solidFill>
             <a:schemeClr val="tx1"/>
           </a:solidFill>
@@ -3728,8 +3735,8 @@
           <a:cs typeface="+mn-cs"/>
         </a:defRPr>
       </a:lvl4pPr>
-      <a:lvl5pPr algn="l" defTabSz="342900" eaLnBrk="1" hangingPunct="1" latinLnBrk="0" marL="1371600" rtl="0">
-        <a:defRPr kern="1200" sz="1350">
+      <a:lvl5pPr marL="1371600" algn="l" defTabSz="342900" rtl="0" eaLnBrk="1" latinLnBrk="0" hangingPunct="1">
+        <a:defRPr sz="1350" kern="1200">
           <a:solidFill>
             <a:schemeClr val="tx1"/>
           </a:solidFill>
@@ -3738,8 +3745,8 @@
           <a:cs typeface="+mn-cs"/>
         </a:defRPr>
       </a:lvl5pPr>
-      <a:lvl6pPr algn="l" defTabSz="342900" eaLnBrk="1" hangingPunct="1" latinLnBrk="0" marL="1714500" rtl="0">
-        <a:defRPr kern="1200" sz="1350">
+      <a:lvl6pPr marL="1714500" algn="l" defTabSz="342900" rtl="0" eaLnBrk="1" latinLnBrk="0" hangingPunct="1">
+        <a:defRPr sz="1350" kern="1200">
           <a:solidFill>
             <a:schemeClr val="tx1"/>
           </a:solidFill>
@@ -3748,8 +3755,8 @@
           <a:cs typeface="+mn-cs"/>
         </a:defRPr>
       </a:lvl6pPr>
-      <a:lvl7pPr algn="l" defTabSz="342900" eaLnBrk="1" hangingPunct="1" latinLnBrk="0" marL="2057400" rtl="0">
-        <a:defRPr kern="1200" sz="1350">
+      <a:lvl7pPr marL="2057400" algn="l" defTabSz="342900" rtl="0" eaLnBrk="1" latinLnBrk="0" hangingPunct="1">
+        <a:defRPr sz="1350" kern="1200">
           <a:solidFill>
             <a:schemeClr val="tx1"/>
           </a:solidFill>
@@ -3758,8 +3765,8 @@
           <a:cs typeface="+mn-cs"/>
         </a:defRPr>
       </a:lvl7pPr>
-      <a:lvl8pPr algn="l" defTabSz="342900" eaLnBrk="1" hangingPunct="1" latinLnBrk="0" marL="2400300" rtl="0">
-        <a:defRPr kern="1200" sz="1350">
+      <a:lvl8pPr marL="2400300" algn="l" defTabSz="342900" rtl="0" eaLnBrk="1" latinLnBrk="0" hangingPunct="1">
+        <a:defRPr sz="1350" kern="1200">
           <a:solidFill>
             <a:schemeClr val="tx1"/>
           </a:solidFill>
@@ -3768,8 +3775,8 @@
           <a:cs typeface="+mn-cs"/>
         </a:defRPr>
       </a:lvl8pPr>
-      <a:lvl9pPr algn="l" defTabSz="342900" eaLnBrk="1" hangingPunct="1" latinLnBrk="0" marL="2743200" rtl="0">
-        <a:defRPr kern="1200" sz="1350">
+      <a:lvl9pPr marL="2743200" algn="l" defTabSz="342900" rtl="0" eaLnBrk="1" latinLnBrk="0" hangingPunct="1">
+        <a:defRPr sz="1350" kern="1200">
           <a:solidFill>
             <a:schemeClr val="tx1"/>
           </a:solidFill>
@@ -3817,14 +3824,15 @@
           </a:xfrm>
         </p:spPr>
         <p:txBody>
-          <a:bodyPr/>
-          <a:lstStyle/>
-          <a:p>
-            <a:pPr lvl="0" indent="0" marL="0">
+          <a:bodyPr>
+            <a:normAutofit fontScale="90000"/>
+          </a:bodyPr>
+          <a:lstStyle/>
+          <a:p>
+            <a:pPr marL="0" lvl="0" indent="0">
               <a:buNone/>
             </a:pPr>
             <a:r>
-              <a:rPr/>
               <a:t>Copilot Instruction File Constraints: Folders, Filenames, and the Chat Modes → Agents Rename</a:t>
             </a:r>
           </a:p>
@@ -3837,7 +3845,7 @@
             <a:spLocks noGrp="1"/>
           </p:cNvSpPr>
           <p:nvPr>
-            <p:ph idx="1" type="subTitle"/>
+            <p:ph type="subTitle" idx="1"/>
           </p:nvPr>
         </p:nvSpPr>
         <p:spPr>
@@ -3850,16 +3858,20 @@
           <a:bodyPr/>
           <a:lstStyle/>
           <a:p>
-            <a:pPr lvl="0" indent="0" marL="0">
+            <a:pPr marL="0" lvl="0" indent="0">
               <a:buNone/>
             </a:pPr>
             <a:br/>
             <a:br/>
+            <a:endParaRPr/>
           </a:p>
         </p:txBody>
       </p:sp>
     </p:spTree>
   </p:cSld>
+  <p:clrMapOvr>
+    <a:masterClrMapping/>
+  </p:clrMapOvr>
 </p:sld>
 </file>
 
@@ -3900,11 +3912,10 @@
           <a:bodyPr/>
           <a:lstStyle/>
           <a:p>
-            <a:pPr lvl="0" indent="0" marL="0">
+            <a:pPr marL="0" lvl="0" indent="0">
               <a:buNone/>
             </a:pPr>
             <a:r>
-              <a:rPr/>
               <a:t>Agents (Formerly Chat Modes)</a:t>
             </a:r>
           </a:p>
@@ -3912,6 +3923,9 @@
       </p:sp>
     </p:spTree>
   </p:cSld>
+  <p:clrMapOvr>
+    <a:masterClrMapping/>
+  </p:clrMapOvr>
 </p:sld>
 </file>
 
@@ -3947,11 +3961,10 @@
           <a:bodyPr/>
           <a:lstStyle/>
           <a:p>
-            <a:pPr lvl="0" indent="0" marL="0">
+            <a:pPr marL="0" lvl="0" indent="0">
               <a:buNone/>
             </a:pPr>
             <a:r>
-              <a:rPr/>
               <a:t>Folder and Filename Constraints</a:t>
             </a:r>
           </a:p>
@@ -3972,7 +3985,7 @@
           <a:bodyPr/>
           <a:lstStyle/>
           <a:p>
-            <a:pPr lvl="0" indent="0" marL="0">
+            <a:pPr marL="0" lvl="0" indent="0">
               <a:buNone/>
             </a:pPr>
             <a:r>
@@ -3984,6 +3997,150 @@
       </p:sp>
     </p:spTree>
   </p:cSld>
+  <p:clrMapOvr>
+    <a:masterClrMapping/>
+  </p:clrMapOvr>
+</p:sld>
+</file>
+
+<file path=ppt/slides/slide12.xml><?xml version="1.0" encoding="utf-8"?>
+<p:sld xmlns:a="http://schemas.openxmlformats.org/drawingml/2006/main" xmlns:r="http://schemas.openxmlformats.org/officeDocument/2006/relationships" xmlns:p="http://schemas.openxmlformats.org/presentationml/2006/main">
+  <p:cSld>
+    <p:spTree>
+      <p:nvGrpSpPr>
+        <p:cNvPr id="1" name=""/>
+        <p:cNvGrpSpPr/>
+        <p:nvPr/>
+      </p:nvGrpSpPr>
+      <p:grpSpPr>
+        <a:xfrm>
+          <a:off x="0" y="0"/>
+          <a:ext cx="0" cy="0"/>
+          <a:chOff x="0" y="0"/>
+          <a:chExt cx="0" cy="0"/>
+        </a:xfrm>
+      </p:grpSpPr>
+      <p:sp>
+        <p:nvSpPr>
+          <p:cNvPr id="2" name="Title 1"/>
+          <p:cNvSpPr>
+            <a:spLocks noGrp="1"/>
+          </p:cNvSpPr>
+          <p:nvPr>
+            <p:ph type="title"/>
+          </p:nvPr>
+        </p:nvSpPr>
+        <p:spPr/>
+        <p:txBody>
+          <a:bodyPr>
+            <a:normAutofit/>
+          </a:bodyPr>
+          <a:lstStyle/>
+          <a:p>
+            <a:pPr marL="0" lvl="0" indent="0">
+              <a:buNone/>
+            </a:pPr>
+            <a:r>
+              <a:t>Custom Chat Modes Best Practices</a:t>
+            </a:r>
+          </a:p>
+        </p:txBody>
+      </p:sp>
+      <p:sp>
+        <p:nvSpPr>
+          <p:cNvPr id="3" name="Content Placeholder 2"/>
+          <p:cNvSpPr>
+            <a:spLocks noGrp="1"/>
+          </p:cNvSpPr>
+          <p:nvPr>
+            <p:ph idx="1"/>
+          </p:nvPr>
+        </p:nvSpPr>
+        <p:spPr/>
+        <p:txBody>
+          <a:bodyPr>
+            <a:normAutofit fontScale="77500" lnSpcReduction="20000"/>
+          </a:bodyPr>
+          <a:lstStyle/>
+          <a:p>
+            <a:pPr marL="0" lvl="0" indent="0">
+              <a:spcBef>
+                <a:spcPts val="3000"/>
+              </a:spcBef>
+              <a:buNone/>
+            </a:pPr>
+            <a:r>
+              <a:rPr b="1"/>
+              <a:t>✅ Do This:</a:t>
+            </a:r>
+          </a:p>
+          <a:p>
+            <a:pPr lvl="0"/>
+            <a:r>
+              <a:t>Define clear expertise boundaries</a:t>
+            </a:r>
+          </a:p>
+          <a:p>
+            <a:pPr lvl="0"/>
+            <a:r>
+              <a:t>Provide rich contextual background</a:t>
+            </a:r>
+          </a:p>
+          <a:p>
+            <a:pPr lvl="0"/>
+            <a:r>
+              <a:t>Establish consistent personality/voice</a:t>
+            </a:r>
+          </a:p>
+          <a:p>
+            <a:pPr lvl="0"/>
+            <a:r>
+              <a:t>Include relevant constraints and preferences</a:t>
+            </a:r>
+          </a:p>
+          <a:p>
+            <a:pPr marL="0" lvl="0" indent="0">
+              <a:spcBef>
+                <a:spcPts val="3000"/>
+              </a:spcBef>
+              <a:buNone/>
+            </a:pPr>
+            <a:r>
+              <a:rPr b="1"/>
+              <a:t>❌ Avoid This:</a:t>
+            </a:r>
+          </a:p>
+          <a:p>
+            <a:pPr lvl="0"/>
+            <a:r>
+              <a:t>Conflicting expertise claims</a:t>
+            </a:r>
+          </a:p>
+          <a:p>
+            <a:pPr lvl="0"/>
+            <a:r>
+              <a:t>Too broad or unfocused roles</a:t>
+            </a:r>
+          </a:p>
+          <a:p>
+            <a:pPr lvl="0"/>
+            <a:r>
+              <a:t>Personality that conflicts with task needs</a:t>
+            </a:r>
+          </a:p>
+          <a:p>
+            <a:pPr lvl="0"/>
+            <a:r>
+              <a:t>Missing essential domain knowledge</a:t>
+            </a:r>
+          </a:p>
+        </p:txBody>
+      </p:sp>
+    </p:spTree>
+  </p:cSld>
+  <p:clrMapOvr>
+    <a:masterClrMapping/>
+  </p:clrMapOvr>
 </p:sld>
 </file>
 
@@ -4024,11 +4181,10 @@
           <a:bodyPr/>
           <a:lstStyle/>
           <a:p>
-            <a:pPr lvl="0" indent="0" marL="0">
+            <a:pPr marL="0" lvl="0" indent="0">
               <a:buNone/>
             </a:pPr>
             <a:r>
-              <a:rPr/>
               <a:t>Copilot Instruction File Constraints</a:t>
             </a:r>
           </a:p>
@@ -4036,6 +4192,9 @@
       </p:sp>
     </p:spTree>
   </p:cSld>
+  <p:clrMapOvr>
+    <a:masterClrMapping/>
+  </p:clrMapOvr>
 </p:sld>
 </file>
 
@@ -4068,14 +4227,15 @@
         </p:nvSpPr>
         <p:spPr/>
         <p:txBody>
-          <a:bodyPr/>
-          <a:lstStyle/>
-          <a:p>
-            <a:pPr lvl="0" indent="0" marL="0">
+          <a:bodyPr>
+            <a:normAutofit fontScale="90000"/>
+          </a:bodyPr>
+          <a:lstStyle/>
+          <a:p>
+            <a:pPr marL="0" lvl="0" indent="0">
               <a:buNone/>
             </a:pPr>
             <a:r>
-              <a:rPr/>
               <a:t>Folders, Filenames, and the Chat Modes → Agents Transition</a:t>
             </a:r>
           </a:p>
@@ -4083,6 +4243,9 @@
       </p:sp>
     </p:spTree>
   </p:cSld>
+  <p:clrMapOvr>
+    <a:masterClrMapping/>
+  </p:clrMapOvr>
 </p:sld>
 </file>
 
@@ -4123,11 +4286,10 @@
           <a:bodyPr/>
           <a:lstStyle/>
           <a:p>
-            <a:pPr lvl="0" indent="0" marL="0">
+            <a:pPr marL="0" lvl="0" indent="0">
               <a:buNone/>
             </a:pPr>
             <a:r>
-              <a:rPr/>
               <a:t>Why Constraints Matter</a:t>
             </a:r>
           </a:p>
@@ -4135,6 +4297,9 @@
       </p:sp>
     </p:spTree>
   </p:cSld>
+  <p:clrMapOvr>
+    <a:masterClrMapping/>
+  </p:clrMapOvr>
 </p:sld>
 </file>
 
@@ -4170,11 +4335,10 @@
           <a:bodyPr/>
           <a:lstStyle/>
           <a:p>
-            <a:pPr lvl="0" indent="0" marL="0">
+            <a:pPr marL="0" lvl="0" indent="0">
               <a:buNone/>
             </a:pPr>
             <a:r>
-              <a:rPr/>
               <a:t>Predictability • Auditability • Determinism</a:t>
             </a:r>
           </a:p>
@@ -4197,7 +4361,6 @@
           <a:p>
             <a:pPr lvl="0"/>
             <a:r>
-              <a:rPr/>
               <a:t>Copilot loads files only from </a:t>
             </a:r>
             <a:r>
@@ -4208,7 +4371,6 @@
           <a:p>
             <a:pPr lvl="0"/>
             <a:r>
-              <a:rPr/>
               <a:t>Filenames must match </a:t>
             </a:r>
             <a:r>
@@ -4219,21 +4381,18 @@
           <a:p>
             <a:pPr lvl="0"/>
             <a:r>
-              <a:rPr/>
               <a:t>No recursion, no aliases, no alternative casing</a:t>
             </a:r>
           </a:p>
           <a:p>
             <a:pPr lvl="0"/>
             <a:r>
-              <a:rPr/>
               <a:t>Misplaced files are silently ignored</a:t>
             </a:r>
           </a:p>
           <a:p>
             <a:pPr lvl="0"/>
             <a:r>
-              <a:rPr/>
               <a:t>The rename to </a:t>
             </a:r>
             <a:r>
@@ -4241,7 +4400,6 @@
               <a:t>agents</a:t>
             </a:r>
             <a:r>
-              <a:rPr/>
               <a:t> does not change folder rules (yet)</a:t>
             </a:r>
           </a:p>
@@ -4249,6 +4407,9 @@
       </p:sp>
     </p:spTree>
   </p:cSld>
+  <p:clrMapOvr>
+    <a:masterClrMapping/>
+  </p:clrMapOvr>
 </p:sld>
 </file>
 
@@ -4289,11 +4450,10 @@
           <a:bodyPr/>
           <a:lstStyle/>
           <a:p>
-            <a:pPr lvl="0" indent="0" marL="0">
+            <a:pPr marL="0" lvl="0" indent="0">
               <a:buNone/>
             </a:pPr>
             <a:r>
-              <a:rPr/>
               <a:t>High-Level Overview</a:t>
             </a:r>
           </a:p>
@@ -4301,6 +4461,9 @@
       </p:sp>
     </p:spTree>
   </p:cSld>
+  <p:clrMapOvr>
+    <a:masterClrMapping/>
+  </p:clrMapOvr>
 </p:sld>
 </file>
 
@@ -4336,11 +4499,10 @@
           <a:bodyPr/>
           <a:lstStyle/>
           <a:p>
-            <a:pPr lvl="0" indent="0" marL="0">
+            <a:pPr marL="0" lvl="0" indent="0">
               <a:buNone/>
             </a:pPr>
             <a:r>
-              <a:rPr/>
               <a:t>What Copilot Looks For</a:t>
             </a:r>
           </a:p>
@@ -4358,7 +4520,7 @@
         </p:nvGraphicFramePr>
         <p:xfrm>
           <a:off x="457200" y="1193800"/>
-          <a:ext cx="8229600" cy="3390900"/>
+          <a:ext cx="8242300" cy="3223260"/>
         </p:xfrm>
         <a:graphic>
           <a:graphicData uri="http://schemas.openxmlformats.org/drawingml/2006/table">
@@ -4367,10 +4529,34 @@
                 <a:tableStyleId>{5C22544A-7EE6-4342-B048-85BDC9FD1C3A}</a:tableStyleId>
               </a:tblPr>
               <a:tblGrid>
-                <a:gridCol w="2171700"/>
-                <a:gridCol w="2603500"/>
-                <a:gridCol w="2451100"/>
-                <a:gridCol w="1016000"/>
+                <a:gridCol w="2171700">
+                  <a:extLst>
+                    <a:ext uri="{9D8B030D-6E8A-4147-A177-3AD203B41FA5}">
+                      <a16:colId xmlns:a16="http://schemas.microsoft.com/office/drawing/2014/main" val="20000"/>
+                    </a:ext>
+                  </a:extLst>
+                </a:gridCol>
+                <a:gridCol w="2603500">
+                  <a:extLst>
+                    <a:ext uri="{9D8B030D-6E8A-4147-A177-3AD203B41FA5}">
+                      <a16:colId xmlns:a16="http://schemas.microsoft.com/office/drawing/2014/main" val="20001"/>
+                    </a:ext>
+                  </a:extLst>
+                </a:gridCol>
+                <a:gridCol w="2451100">
+                  <a:extLst>
+                    <a:ext uri="{9D8B030D-6E8A-4147-A177-3AD203B41FA5}">
+                      <a16:colId xmlns:a16="http://schemas.microsoft.com/office/drawing/2014/main" val="20002"/>
+                    </a:ext>
+                  </a:extLst>
+                </a:gridCol>
+                <a:gridCol w="1016000">
+                  <a:extLst>
+                    <a:ext uri="{9D8B030D-6E8A-4147-A177-3AD203B41FA5}">
+                      <a16:colId xmlns:a16="http://schemas.microsoft.com/office/drawing/2014/main" val="20003"/>
+                    </a:ext>
+                  </a:extLst>
+                </a:gridCol>
               </a:tblGrid>
               <a:tr h="0">
                 <a:tc>
@@ -4378,11 +4564,10 @@
                     <a:bodyPr/>
                     <a:lstStyle/>
                     <a:p>
-                      <a:pPr lvl="0" indent="0" marL="0">
+                      <a:pPr marL="0" lvl="0" indent="0">
                         <a:buNone/>
                       </a:pPr>
                       <a:r>
-                        <a:rPr/>
                         <a:t>Artifact Type</a:t>
                       </a:r>
                     </a:p>
@@ -4394,11 +4579,10 @@
                     <a:bodyPr/>
                     <a:lstStyle/>
                     <a:p>
-                      <a:pPr lvl="0" indent="0" marL="0">
+                      <a:pPr marL="0" lvl="0" indent="0">
                         <a:buNone/>
                       </a:pPr>
                       <a:r>
-                        <a:rPr/>
                         <a:t>Required Location</a:t>
                       </a:r>
                     </a:p>
@@ -4410,11 +4594,10 @@
                     <a:bodyPr/>
                     <a:lstStyle/>
                     <a:p>
-                      <a:pPr lvl="0" indent="0" marL="0">
+                      <a:pPr marL="0" lvl="0" indent="0">
                         <a:buNone/>
                       </a:pPr>
                       <a:r>
-                        <a:rPr/>
                         <a:t>Required Format</a:t>
                       </a:r>
                     </a:p>
@@ -4426,17 +4609,21 @@
                     <a:bodyPr/>
                     <a:lstStyle/>
                     <a:p>
-                      <a:pPr lvl="0" indent="0" marL="0">
+                      <a:pPr marL="0" lvl="0" indent="0">
                         <a:buNone/>
                       </a:pPr>
                       <a:r>
-                        <a:rPr/>
                         <a:t>Notes</a:t>
                       </a:r>
                     </a:p>
                   </a:txBody>
                   <a:tcPr/>
                 </a:tc>
+                <a:extLst>
+                  <a:ext uri="{0D108BD9-81ED-4DB2-BD59-A6C34878D82A}">
+                    <a16:rowId xmlns:a16="http://schemas.microsoft.com/office/drawing/2014/main" val="10000"/>
+                  </a:ext>
+                </a:extLst>
               </a:tr>
               <a:tr h="0">
                 <a:tc>
@@ -4444,61 +4631,66 @@
                     <a:bodyPr/>
                     <a:lstStyle/>
                     <a:p>
-                      <a:pPr lvl="0" indent="0" marL="0">
+                      <a:pPr marL="0" lvl="0" indent="0">
                         <a:buNone/>
                       </a:pPr>
                       <a:r>
-                        <a:rPr/>
                         <a:t>Org guardrails</a:t>
                       </a:r>
                     </a:p>
                   </a:txBody>
+                  <a:tcPr/>
                 </a:tc>
                 <a:tc>
                   <a:txBody>
                     <a:bodyPr/>
                     <a:lstStyle/>
                     <a:p>
-                      <a:pPr lvl="0" indent="0" marL="0">
+                      <a:pPr marL="0" lvl="0" indent="0">
                         <a:buNone/>
                       </a:pPr>
                       <a:r>
-                        <a:rPr/>
                         <a:t>Org settings</a:t>
                       </a:r>
                     </a:p>
                   </a:txBody>
+                  <a:tcPr/>
                 </a:tc>
                 <a:tc>
                   <a:txBody>
                     <a:bodyPr/>
                     <a:lstStyle/>
                     <a:p>
-                      <a:pPr lvl="0" indent="0" marL="0">
+                      <a:pPr marL="0" lvl="0" indent="0">
                         <a:buNone/>
                       </a:pPr>
                       <a:r>
-                        <a:rPr/>
                         <a:t>UI-managed</a:t>
                       </a:r>
                     </a:p>
                   </a:txBody>
+                  <a:tcPr/>
                 </a:tc>
                 <a:tc>
                   <a:txBody>
                     <a:bodyPr/>
                     <a:lstStyle/>
                     <a:p>
-                      <a:pPr lvl="0" indent="0" marL="0">
+                      <a:pPr marL="0" lvl="0" indent="0">
                         <a:buNone/>
                       </a:pPr>
                       <a:r>
-                        <a:rPr/>
                         <a:t>Always included</a:t>
                       </a:r>
                     </a:p>
                   </a:txBody>
+                  <a:tcPr/>
                 </a:tc>
+                <a:extLst>
+                  <a:ext uri="{0D108BD9-81ED-4DB2-BD59-A6C34878D82A}">
+                    <a16:rowId xmlns:a16="http://schemas.microsoft.com/office/drawing/2014/main" val="10001"/>
+                  </a:ext>
+                </a:extLst>
               </a:tr>
               <a:tr h="0">
                 <a:tc>
@@ -4506,22 +4698,22 @@
                     <a:bodyPr/>
                     <a:lstStyle/>
                     <a:p>
-                      <a:pPr lvl="0" indent="0" marL="0">
+                      <a:pPr marL="0" lvl="0" indent="0">
                         <a:buNone/>
                       </a:pPr>
                       <a:r>
-                        <a:rPr/>
                         <a:t>Repo guardrails</a:t>
                       </a:r>
                     </a:p>
                   </a:txBody>
+                  <a:tcPr/>
                 </a:tc>
                 <a:tc>
                   <a:txBody>
                     <a:bodyPr/>
                     <a:lstStyle/>
                     <a:p>
-                      <a:pPr lvl="0" indent="0" marL="0">
+                      <a:pPr marL="0" lvl="0" indent="0">
                         <a:buNone/>
                       </a:pPr>
                       <a:r>
@@ -4532,13 +4724,14 @@
                       </a:r>
                     </a:p>
                   </a:txBody>
+                  <a:tcPr/>
                 </a:tc>
                 <a:tc>
                   <a:txBody>
                     <a:bodyPr/>
                     <a:lstStyle/>
                     <a:p>
-                      <a:pPr lvl="0" indent="0" marL="0">
+                      <a:pPr marL="0" lvl="0" indent="0">
                         <a:buNone/>
                       </a:pPr>
                       <a:r>
@@ -4549,22 +4742,28 @@
                       </a:r>
                     </a:p>
                   </a:txBody>
+                  <a:tcPr/>
                 </a:tc>
                 <a:tc>
                   <a:txBody>
                     <a:bodyPr/>
                     <a:lstStyle/>
                     <a:p>
-                      <a:pPr lvl="0" indent="0" marL="0">
+                      <a:pPr marL="0" lvl="0" indent="0">
                         <a:buNone/>
                       </a:pPr>
                       <a:r>
-                        <a:rPr/>
                         <a:t>Always included</a:t>
                       </a:r>
                     </a:p>
                   </a:txBody>
+                  <a:tcPr/>
                 </a:tc>
+                <a:extLst>
+                  <a:ext uri="{0D108BD9-81ED-4DB2-BD59-A6C34878D82A}">
+                    <a16:rowId xmlns:a16="http://schemas.microsoft.com/office/drawing/2014/main" val="10002"/>
+                  </a:ext>
+                </a:extLst>
               </a:tr>
               <a:tr h="0">
                 <a:tc>
@@ -4572,37 +4771,37 @@
                     <a:bodyPr/>
                     <a:lstStyle/>
                     <a:p>
-                      <a:pPr lvl="0" indent="0" marL="0">
+                      <a:pPr marL="0" lvl="0" indent="0">
                         <a:buNone/>
                       </a:pPr>
                       <a:r>
-                        <a:rPr/>
                         <a:t>Path-scoped guardrails</a:t>
                       </a:r>
                     </a:p>
                   </a:txBody>
+                  <a:tcPr/>
                 </a:tc>
                 <a:tc>
                   <a:txBody>
                     <a:bodyPr/>
                     <a:lstStyle/>
                     <a:p>
-                      <a:pPr lvl="0" indent="0" marL="0">
+                      <a:pPr marL="0" lvl="0" indent="0">
                         <a:buNone/>
                       </a:pPr>
                       <a:r>
-                        <a:rPr/>
                         <a:t>Any folder</a:t>
                       </a:r>
                     </a:p>
                   </a:txBody>
+                  <a:tcPr/>
                 </a:tc>
                 <a:tc>
                   <a:txBody>
                     <a:bodyPr/>
                     <a:lstStyle/>
                     <a:p>
-                      <a:pPr lvl="0" indent="0" marL="0">
+                      <a:pPr marL="0" lvl="0" indent="0">
                         <a:buNone/>
                       </a:pPr>
                       <a:r>
@@ -4613,22 +4812,28 @@
                       </a:r>
                     </a:p>
                   </a:txBody>
+                  <a:tcPr/>
                 </a:tc>
                 <a:tc>
                   <a:txBody>
                     <a:bodyPr/>
                     <a:lstStyle/>
                     <a:p>
-                      <a:pPr lvl="0" indent="0" marL="0">
+                      <a:pPr marL="0" lvl="0" indent="0">
                         <a:buNone/>
                       </a:pPr>
                       <a:r>
-                        <a:rPr/>
                         <a:t>Applies to subtree</a:t>
                       </a:r>
                     </a:p>
                   </a:txBody>
+                  <a:tcPr/>
                 </a:tc>
+                <a:extLst>
+                  <a:ext uri="{0D108BD9-81ED-4DB2-BD59-A6C34878D82A}">
+                    <a16:rowId xmlns:a16="http://schemas.microsoft.com/office/drawing/2014/main" val="10003"/>
+                  </a:ext>
+                </a:extLst>
               </a:tr>
               <a:tr h="0">
                 <a:tc>
@@ -4636,7 +4841,7 @@
                     <a:bodyPr/>
                     <a:lstStyle/>
                     <a:p>
-                      <a:pPr lvl="0" indent="0" marL="0">
+                      <a:pPr marL="0" lvl="0" indent="0">
                         <a:buNone/>
                       </a:pPr>
                       <a:r>
@@ -4645,13 +4850,14 @@
                       </a:r>
                     </a:p>
                   </a:txBody>
+                  <a:tcPr/>
                 </a:tc>
                 <a:tc>
                   <a:txBody>
                     <a:bodyPr/>
                     <a:lstStyle/>
                     <a:p>
-                      <a:pPr lvl="0" indent="0" marL="0">
+                      <a:pPr marL="0" lvl="0" indent="0">
                         <a:buNone/>
                       </a:pPr>
                       <a:r>
@@ -4662,13 +4868,14 @@
                       </a:r>
                     </a:p>
                   </a:txBody>
+                  <a:tcPr/>
                 </a:tc>
                 <a:tc>
                   <a:txBody>
                     <a:bodyPr/>
                     <a:lstStyle/>
                     <a:p>
-                      <a:pPr lvl="0" indent="0" marL="0">
+                      <a:pPr marL="0" lvl="0" indent="0">
                         <a:buNone/>
                       </a:pPr>
                       <a:r>
@@ -4678,7 +4885,6 @@
                         <a:t>.json</a:t>
                       </a:r>
                       <a:r>
-                        <a:rPr/>
                         <a:t> or </a:t>
                       </a:r>
                       <a:r>
@@ -4689,22 +4895,28 @@
                       </a:r>
                     </a:p>
                   </a:txBody>
+                  <a:tcPr/>
                 </a:tc>
                 <a:tc>
                   <a:txBody>
                     <a:bodyPr/>
                     <a:lstStyle/>
                     <a:p>
-                      <a:pPr lvl="0" indent="0" marL="0">
+                      <a:pPr marL="0" lvl="0" indent="0">
                         <a:buNone/>
                       </a:pPr>
                       <a:r>
-                        <a:rPr/>
                         <a:t>Folder name has NOT changed</a:t>
                       </a:r>
                     </a:p>
                   </a:txBody>
+                  <a:tcPr/>
                 </a:tc>
+                <a:extLst>
+                  <a:ext uri="{0D108BD9-81ED-4DB2-BD59-A6C34878D82A}">
+                    <a16:rowId xmlns:a16="http://schemas.microsoft.com/office/drawing/2014/main" val="10004"/>
+                  </a:ext>
+                </a:extLst>
               </a:tr>
               <a:tr h="0">
                 <a:tc>
@@ -4712,22 +4924,22 @@
                     <a:bodyPr/>
                     <a:lstStyle/>
                     <a:p>
-                      <a:pPr lvl="0" indent="0" marL="0">
+                      <a:pPr marL="0" lvl="0" indent="0">
                         <a:buNone/>
                       </a:pPr>
                       <a:r>
-                        <a:rPr/>
                         <a:t>Promptfiles</a:t>
                       </a:r>
                     </a:p>
                   </a:txBody>
+                  <a:tcPr/>
                 </a:tc>
                 <a:tc>
                   <a:txBody>
                     <a:bodyPr/>
                     <a:lstStyle/>
                     <a:p>
-                      <a:pPr lvl="0" indent="0" marL="0">
+                      <a:pPr marL="0" lvl="0" indent="0">
                         <a:buNone/>
                       </a:pPr>
                       <a:r>
@@ -4738,13 +4950,14 @@
                       </a:r>
                     </a:p>
                   </a:txBody>
+                  <a:tcPr/>
                 </a:tc>
                 <a:tc>
                   <a:txBody>
                     <a:bodyPr/>
                     <a:lstStyle/>
                     <a:p>
-                      <a:pPr lvl="0" indent="0" marL="0">
+                      <a:pPr marL="0" lvl="0" indent="0">
                         <a:buNone/>
                       </a:pPr>
                       <a:r>
@@ -4755,22 +4968,28 @@
                       </a:r>
                     </a:p>
                   </a:txBody>
+                  <a:tcPr/>
                 </a:tc>
                 <a:tc>
                   <a:txBody>
                     <a:bodyPr/>
                     <a:lstStyle/>
                     <a:p>
-                      <a:pPr lvl="0" indent="0" marL="0">
+                      <a:pPr marL="0" lvl="0" indent="0">
                         <a:buNone/>
                       </a:pPr>
                       <a:r>
-                        <a:rPr/>
                         <a:t>Only when invoked</a:t>
                       </a:r>
                     </a:p>
                   </a:txBody>
+                  <a:tcPr/>
                 </a:tc>
+                <a:extLst>
+                  <a:ext uri="{0D108BD9-81ED-4DB2-BD59-A6C34878D82A}">
+                    <a16:rowId xmlns:a16="http://schemas.microsoft.com/office/drawing/2014/main" val="10005"/>
+                  </a:ext>
+                </a:extLst>
               </a:tr>
             </a:tbl>
           </a:graphicData>
@@ -4778,6 +4997,9 @@
       </p:graphicFrame>
     </p:spTree>
   </p:cSld>
+  <p:clrMapOvr>
+    <a:masterClrMapping/>
+  </p:clrMapOvr>
 </p:sld>
 </file>
 
@@ -4818,11 +5040,10 @@
           <a:bodyPr/>
           <a:lstStyle/>
           <a:p>
-            <a:pPr lvl="0" indent="0" marL="0">
+            <a:pPr marL="0" lvl="0" indent="0">
               <a:buNone/>
             </a:pPr>
             <a:r>
-              <a:rPr/>
               <a:t>The Rename: Chat Modes → Agents</a:t>
             </a:r>
           </a:p>
@@ -4830,6 +5051,9 @@
       </p:sp>
     </p:spTree>
   </p:cSld>
+  <p:clrMapOvr>
+    <a:masterClrMapping/>
+  </p:clrMapOvr>
 </p:sld>
 </file>
 
@@ -4865,11 +5089,10 @@
           <a:bodyPr/>
           <a:lstStyle/>
           <a:p>
-            <a:pPr lvl="0" indent="0" marL="0">
+            <a:pPr marL="0" lvl="0" indent="0">
               <a:buNone/>
             </a:pPr>
             <a:r>
-              <a:rPr/>
               <a:t>What’s Changing and What Isn’t</a:t>
             </a:r>
           </a:p>
@@ -4890,7 +5113,7 @@
           <a:bodyPr/>
           <a:lstStyle/>
           <a:p>
-            <a:pPr lvl="0" indent="0" marL="0">
+            <a:pPr marL="0" lvl="0" indent="0">
               <a:buNone/>
             </a:pPr>
             <a:r>
@@ -4898,12 +5121,11 @@
               <a:t>Changing:</a:t>
             </a:r>
             <a:r>
-              <a:rPr/>
               <a:t> - Terminology in UI and documentation - Conceptual framing (agents = more powerful, structured roles) - Schema will expand over time</a:t>
             </a:r>
           </a:p>
           <a:p>
-            <a:pPr lvl="0" indent="0" marL="0">
+            <a:pPr marL="0" lvl="0" indent="0">
               <a:buNone/>
             </a:pPr>
             <a:r>
@@ -4911,7 +5133,6 @@
               <a:t>Not changing (yet):</a:t>
             </a:r>
             <a:r>
-              <a:rPr/>
               <a:t> - Folder name: </a:t>
             </a:r>
             <a:r>
@@ -4921,7 +5142,6 @@
               <a:t>.github/copilot/chat_modes/</a:t>
             </a:r>
             <a:r>
-              <a:rPr/>
               <a:t> - File discovery rules - Filename requirements - Promptfile behavior - Instruction stack mechanics</a:t>
             </a:r>
           </a:p>
@@ -4929,6 +5149,9 @@
       </p:sp>
     </p:spTree>
   </p:cSld>
+  <p:clrMapOvr>
+    <a:masterClrMapping/>
+  </p:clrMapOvr>
 </p:sld>
 </file>
 

</xml_diff>